<commit_message>
Add template preview IQVIA-test
</commit_message>
<xml_diff>
--- a/templates/IQVIA-test-preview.pptx
+++ b/templates/IQVIA-test-preview.pptx
@@ -34458,28 +34458,7 @@
       <p:grpSpPr/>
       <p:sp>
         <p:nvSpPr>
-          <p:cNvPr id="2" name="Text Placeholder 1"/>
-          <p:cNvSpPr>
-            <a:spLocks noGrp="1"/>
-          </p:cNvSpPr>
-          <p:nvPr>
-            <p:ph type="body" idx="16" sz="quarter"/>
-          </p:nvPr>
-        </p:nvSpPr>
-        <p:spPr/>
-        <p:txBody>
-          <a:bodyPr/>
-          <a:lstStyle/>
-          <a:p>
-            <a:r>
-              <a:t>EYEBROW</a:t>
-            </a:r>
-          </a:p>
-        </p:txBody>
-      </p:sp>
-      <p:sp>
-        <p:nvSpPr>
-          <p:cNvPr id="3" name="Title 2"/>
+          <p:cNvPr id="2" name="Title 1"/>
           <p:cNvSpPr>
             <a:spLocks noGrp="1"/>
           </p:cNvSpPr>

</xml_diff>